<commit_message>
Use rounded bold font for editable ceremony deck titles/headings
Set Arial Rounded MT Bold for bold text (titles, headings, body) in the
editable build to match the deck's rounded style; keep plain Arial for
pill labels and footers. Title text unchanged.
</commit_message>
<xml_diff>
--- a/PPT_uzbek_editable.pptx
+++ b/PPT_uzbek_editable.pptx
@@ -3141,11 +3141,11 @@
           <a:p>
             <a:pPr algn="ctr"/>
             <a:r>
-              <a:rPr sz="7600" b="1">
+              <a:rPr sz="6900" b="1">
                 <a:solidFill>
                   <a:srgbClr val="0E6CA5"/>
                 </a:solidFill>
-                <a:latin typeface="Arial"/>
+                <a:latin typeface="Arial Rounded MT Bold"/>
               </a:rPr>
               <a:t>Ochilish marosimi</a:t>
             </a:r>
@@ -3218,11 +3218,11 @@
           <a:p>
             <a:pPr algn="l"/>
             <a:r>
-              <a:rPr sz="3300" b="1">
+              <a:rPr sz="3000" b="1">
                 <a:solidFill>
                   <a:srgbClr val="0E6CA5"/>
                 </a:solidFill>
-                <a:latin typeface="Arial"/>
+                <a:latin typeface="Arial Rounded MT Bold"/>
               </a:rPr>
               <a:t>Kirish</a:t>
             </a:r>
@@ -3253,11 +3253,11 @@
           <a:p>
             <a:pPr algn="ctr"/>
             <a:r>
-              <a:rPr sz="4300" b="1">
+              <a:rPr sz="4000" b="1">
                 <a:solidFill>
                   <a:srgbClr val="3C3C3C"/>
                 </a:solidFill>
-                <a:latin typeface="Arial"/>
+                <a:latin typeface="Arial Rounded MT Bold"/>
               </a:rPr>
               <a:t>Men o'qituvchi va o'quvchilar vakilini tanishtirmoqchiman.</a:t>
             </a:r>
@@ -3288,11 +3288,11 @@
           <a:p>
             <a:pPr algn="ctr"/>
             <a:r>
-              <a:rPr sz="4000" b="1">
+              <a:rPr sz="3700" b="1">
                 <a:solidFill>
                   <a:srgbClr val="0E6CA5"/>
                 </a:solidFill>
-                <a:latin typeface="Arial"/>
+                <a:latin typeface="Arial Rounded MT Bold"/>
               </a:rPr>
               <a:t>o'qituvchi: Yu Changho</a:t>
             </a:r>
@@ -3323,11 +3323,11 @@
           <a:p>
             <a:pPr algn="ctr"/>
             <a:r>
-              <a:rPr sz="4000" b="1">
+              <a:rPr sz="3700" b="1">
                 <a:solidFill>
                   <a:srgbClr val="0E6CA5"/>
                 </a:solidFill>
-                <a:latin typeface="Arial"/>
+                <a:latin typeface="Arial Rounded MT Bold"/>
               </a:rPr>
               <a:t>Talabalar vakili: Ryu Inno</a:t>
             </a:r>
@@ -3400,11 +3400,11 @@
           <a:p>
             <a:pPr algn="l"/>
             <a:r>
-              <a:rPr sz="3300" b="1">
+              <a:rPr sz="3000" b="1">
                 <a:solidFill>
                   <a:srgbClr val="0E6CA5"/>
                 </a:solidFill>
-                <a:latin typeface="Arial"/>
+                <a:latin typeface="Arial Rounded MT Bold"/>
               </a:rPr>
               <a:t>Koreya</a:t>
             </a:r>
@@ -3477,11 +3477,11 @@
           <a:p>
             <a:pPr algn="ctr"/>
             <a:r>
-              <a:rPr sz="3200" b="1">
+              <a:rPr sz="2900" b="1">
                 <a:solidFill>
                   <a:srgbClr val="3C3C3C"/>
                 </a:solidFill>
-                <a:latin typeface="Arial"/>
+                <a:latin typeface="Arial Rounded MT Bold"/>
               </a:rPr>
               <a:t>Maktabimiz Janubiy Koreyaning Chonju shahrida joylashgan.</a:t>
             </a:r>
@@ -3729,11 +3729,11 @@
           <a:p>
             <a:pPr algn="l"/>
             <a:r>
-              <a:rPr sz="3300" b="1">
+              <a:rPr sz="3000" b="1">
                 <a:solidFill>
                   <a:srgbClr val="0E6CA5"/>
                 </a:solidFill>
-                <a:latin typeface="Arial"/>
+                <a:latin typeface="Arial Rounded MT Bold"/>
               </a:rPr>
               <a:t>O'quv rejasi</a:t>
             </a:r>
@@ -3764,11 +3764,11 @@
           <a:p>
             <a:pPr algn="ctr"/>
             <a:r>
-              <a:rPr sz="3600" b="1">
+              <a:rPr sz="3400" b="1">
                 <a:solidFill>
                   <a:srgbClr val="3C3C3C"/>
                 </a:solidFill>
-                <a:latin typeface="Arial"/>
+                <a:latin typeface="Arial Rounded MT Bold"/>
               </a:rPr>
               <a:t>Siz to'rtta sohani o'rganasiz.</a:t>
             </a:r>
@@ -3981,11 +3981,11 @@
           <a:p>
             <a:pPr algn="ctr"/>
             <a:r>
-              <a:rPr sz="6200" b="1">
+              <a:rPr sz="5700" b="1">
                 <a:solidFill>
                   <a:srgbClr val="0E6CA5"/>
                 </a:solidFill>
-                <a:latin typeface="Arial"/>
+                <a:latin typeface="Arial Rounded MT Bold"/>
               </a:rPr>
               <a:t>Uchrashuvdan xursandman</a:t>
             </a:r>

</xml_diff>